<commit_message>
customizer: a parametric designer for the finished part — sliders with units and tolerance bands bound to the spec's evidence, switches that fold their dependents, option cards, live draft previews (latest-wins cancellable compiles, adaptive facets), the verified mesh and the mating object ghosted in the 3D view with on-model dimensions, computed values against spec limits, presets in OpenSCAD's parameter-set format, undo/redo, mm/in, Apply & verify that moves the spec with a changed fit dimension; designer conventions for the panel; docs, deck slide, tests
</commit_message>
<xml_diff>
--- a/docs/submission/kintsugi-offgrid-pitch.pptx
+++ b/docs/submission/kintsugi-offgrid-pitch.pptx
@@ -1481,7 +1481,7 @@
           <a:p>
             <a:r>
               <a:rPr lang="en-US" dirty="0"/>
-              <a:t>Product thinking: the person does three things and looks at pictures. The guide never shows a blank screen — every stage has its one next action. The engineer's tabs are there for the curious.</a:t>
+              <a:t>Product thinking: the person does three things and looks at pictures. The guide never shows a blank screen — every stage has its one next action. And the finished part is not a file: it is a parametric designer like MakerWorld's, except every fit dimension shows where its number came from and warns before a check would fail.</a:t>
             </a:r>
             <a:endParaRPr lang="en-US" dirty="0"/>
           </a:p>
@@ -2207,7 +2207,7 @@
       </p:sp>
       <p:pic>
         <p:nvPicPr>
-          <p:cNvPr id="12" name="Image 0" descr="/tmp/claude-0/-home-claude/ccadd335-e104-5fb7-93a7-7cce0c5de540/scratchpad/deck/img/assembly_iso.png">    </p:cNvPr>
+          <p:cNvPr id="12" name="Image 0" descr="/home/claude/kintsugi/docs/submission/img/assembly_iso.png">    </p:cNvPr>
           <p:cNvPicPr>
             <a:picLocks noChangeAspect="1"/>
           </p:cNvPicPr>
@@ -4456,7 +4456,7 @@
                 <a:ea typeface="Courier New" pitchFamily="34" charset="-122"/>
                 <a:cs typeface="Courier New" pitchFamily="34" charset="-120"/>
               </a:rPr>
-              <a:t>79 tests</a:t>
+              <a:t>96 tests</a:t>
             </a:r>
             <a:endParaRPr lang="en-US" sz="1300" dirty="0"/>
           </a:p>
@@ -7139,7 +7139,7 @@
       </p:sp>
       <p:pic>
         <p:nvPicPr>
-          <p:cNvPr id="4" name="Image 0" descr="/tmp/claude-0/-home-claude/ccadd335-e104-5fb7-93a7-7cce0c5de540/scratchpad/deck/img/section_aa.png">    </p:cNvPr>
+          <p:cNvPr id="4" name="Image 0" descr="/home/claude/kintsugi/docs/submission/img/section_aa.png">    </p:cNvPr>
           <p:cNvPicPr>
             <a:picLocks noChangeAspect="1"/>
           </p:cNvPicPr>
@@ -7831,7 +7831,7 @@
       </p:sp>
       <p:pic>
         <p:nvPicPr>
-          <p:cNvPr id="4" name="Image 0" descr="/tmp/claude-0/-home-claude/ccadd335-e104-5fb7-93a7-7cce0c5de540/scratchpad/deck/img/capture_guide.png">    </p:cNvPr>
+          <p:cNvPr id="4" name="Image 0" descr="/home/claude/kintsugi/docs/submission/img/capture_guide.png">    </p:cNvPr>
           <p:cNvPicPr>
             <a:picLocks noChangeAspect="1"/>
           </p:cNvPicPr>
@@ -7881,7 +7881,7 @@
       </p:sp>
       <p:pic>
         <p:nvPicPr>
-          <p:cNvPr id="6" name="Image 1" descr="/tmp/claude-0/-home-claude/ccadd335-e104-5fb7-93a7-7cce0c5de540/scratchpad/deck/img/evidence_map.png">    </p:cNvPr>
+          <p:cNvPr id="6" name="Image 1" descr="/home/claude/kintsugi/docs/submission/img/evidence_map.png">    </p:cNvPr>
           <p:cNvPicPr>
             <a:picLocks noChangeAspect="1"/>
           </p:cNvPicPr>
@@ -8639,7 +8639,7 @@
       </p:sp>
       <p:pic>
         <p:nvPicPr>
-          <p:cNvPr id="4" name="Image 0" descr="/tmp/claude-0/-home-claude/ccadd335-e104-5fb7-93a7-7cce0c5de540/scratchpad/deck/img/graph_pipeline.png">    </p:cNvPr>
+          <p:cNvPr id="4" name="Image 0" descr="/home/claude/kintsugi/docs/submission/img/graph_pipeline.png">    </p:cNvPr>
           <p:cNvPicPr>
             <a:picLocks noChangeAspect="1"/>
           </p:cNvPicPr>
@@ -12666,7 +12666,7 @@
       </p:sp>
       <p:pic>
         <p:nvPicPr>
-          <p:cNvPr id="6" name="Image 0" descr="/tmp/claude-0/-home-claude/ccadd335-e104-5fb7-93a7-7cce0c5de540/scratchpad/deck/img/ab_human_top.png">    </p:cNvPr>
+          <p:cNvPr id="6" name="Image 0" descr="/home/claude/kintsugi/docs/submission/img/ab_human_top.png">    </p:cNvPr>
           <p:cNvPicPr>
             <a:picLocks noChangeAspect="1"/>
           </p:cNvPicPr>
@@ -12716,7 +12716,7 @@
       </p:sp>
       <p:pic>
         <p:nvPicPr>
-          <p:cNvPr id="8" name="Image 1" descr="/tmp/claude-0/-home-claude/ccadd335-e104-5fb7-93a7-7cce0c5de540/scratchpad/deck/img/ab_kin_top.png">    </p:cNvPr>
+          <p:cNvPr id="8" name="Image 1" descr="/home/claude/kintsugi/docs/submission/img/ab_kin_top.png">    </p:cNvPr>
           <p:cNvPicPr>
             <a:picLocks noChangeAspect="1"/>
           </p:cNvPicPr>
@@ -13223,7 +13223,7 @@
                 <a:ea typeface="Courier New" pitchFamily="34" charset="-122"/>
                 <a:cs typeface="Courier New" pitchFamily="34" charset="-120"/>
               </a:rPr>
-              <a:t>79 tests</a:t>
+              <a:t>96 tests</a:t>
             </a:r>
             <a:endParaRPr lang="en-US" sz="1300" dirty="0"/>
           </a:p>
@@ -13476,7 +13476,7 @@
               <a:buNone/>
             </a:pPr>
             <a:r>
-              <a:rPr lang="en-US" sz="3000" b="1" dirty="0">
+              <a:rPr lang="en-US" sz="2600" b="1" dirty="0">
                 <a:solidFill>
                   <a:srgbClr val="18212C"/>
                 </a:solidFill>
@@ -13484,9 +13484,9 @@
                 <a:ea typeface="Arial" pitchFamily="34" charset="-122"/>
                 <a:cs typeface="Arial" pitchFamily="34" charset="-120"/>
               </a:rPr>
-              <a:t>A guide, not a console.</a:t>
-            </a:r>
-            <a:endParaRPr lang="en-US" sz="3000" dirty="0"/>
+              <a:t>A guide, not a console. A part you can change.</a:t>
+            </a:r>
+            <a:endParaRPr lang="en-US" sz="2600" dirty="0"/>
           </a:p>
         </p:txBody>
       </p:sp>
@@ -13519,7 +13519,7 @@
       </p:sp>
       <p:pic>
         <p:nvPicPr>
-          <p:cNvPr id="4" name="Image 0" descr="/tmp/claude-0/-home-claude/ccadd335-e104-5fb7-93a7-7cce0c5de540/scratchpad/deck/img/review.png">    </p:cNvPr>
+          <p:cNvPr id="4" name="Image 0" descr="/home/claude/kintsugi/docs/submission/img/customizer.png">    </p:cNvPr>
           <p:cNvPicPr>
             <a:picLocks noChangeAspect="1"/>
           </p:cNvPicPr>
@@ -13597,7 +13597,7 @@
                 <a:ea typeface="Calibri" pitchFamily="34" charset="-122"/>
                 <a:cs typeface="Calibri" pitchFamily="34" charset="-120"/>
               </a:rPr>
-              <a:t>Six steps on the left, the engineer's view on the right</a:t>
+              <a:t>Sliders that know their evidence</a:t>
             </a:r>
             <a:endParaRPr lang="en-US" sz="1150" dirty="0"/>
           </a:p>
@@ -13636,7 +13636,7 @@
                 <a:ea typeface="Calibri" pitchFamily="34" charset="-122"/>
                 <a:cs typeface="Calibri" pitchFamily="34" charset="-120"/>
               </a:rPr>
-              <a:t>Photos and readings from a phone on the same Wi-Fi; checks, sliders, code, spec and graphs on the desktop.</a:t>
+              <a:t>A live 3D draft on each change; the measured value, its sources and its tolerance band on the rail; computed lengths turn red against the spec before you apply.</a:t>
             </a:r>
             <a:endParaRPr lang="en-US" sz="950" dirty="0"/>
           </a:p>
@@ -13699,7 +13699,7 @@
                 <a:ea typeface="Calibri" pitchFamily="34" charset="-122"/>
                 <a:cs typeface="Calibri" pitchFamily="34" charset="-120"/>
               </a:rPr>
-              <a:t>Coupon before the part</a:t>
+              <a:t>Six steps left, the engineer's view right</a:t>
             </a:r>
             <a:endParaRPr lang="en-US" sz="1150" dirty="0"/>
           </a:p>
@@ -13738,7 +13738,7 @@
                 <a:ea typeface="Calibri" pitchFamily="34" charset="-122"/>
                 <a:cs typeface="Calibri" pitchFamily="34" charset="-120"/>
               </a:rPr>
-              <a:t>Three clearances in one small print; the one that slides on locks the fit.</a:t>
+              <a:t>Photos and readings from a phone on the same Wi-Fi; checks, code, spec and graphs on the desktop.</a:t>
             </a:r>
             <a:endParaRPr lang="en-US" sz="950" dirty="0"/>
           </a:p>
@@ -13801,7 +13801,7 @@
                 <a:ea typeface="Calibri" pitchFamily="34" charset="-122"/>
                 <a:cs typeface="Calibri" pitchFamily="34" charset="-120"/>
               </a:rPr>
-              <a:t>A print card that explains itself</a:t>
+              <a:t>Coupon before the part</a:t>
             </a:r>
             <a:endParaRPr lang="en-US" sz="1150" dirty="0"/>
           </a:p>
@@ -13840,7 +13840,7 @@
                 <a:ea typeface="Calibri" pitchFamily="34" charset="-122"/>
                 <a:cs typeface="Calibri" pitchFamily="34" charset="-120"/>
               </a:rPr>
-              <a:t>Walls, infill, orientation and why — from the load in the spec and the overhang measured on the mesh.</a:t>
+              <a:t>Three clearances in one small print; the one that slides on locks the fit.</a:t>
             </a:r>
             <a:endParaRPr lang="en-US" sz="950" dirty="0"/>
           </a:p>
@@ -13981,7 +13981,7 @@
                 <a:ea typeface="Courier New" pitchFamily="34" charset="-122"/>
                 <a:cs typeface="Courier New" pitchFamily="34" charset="-120"/>
               </a:rPr>
-              <a:t>review step: every hard check green, the critic's verdict, the designer's narration — and one text box to ask for a change</a:t>
+              <a:t>the Customize tab: a draft of the handle after two slider moves, the verified mesh ghosted behind it, the bottle neck in place, Apply &amp; verify one click away</a:t>
             </a:r>
             <a:endParaRPr lang="en-US" sz="850" dirty="0"/>
           </a:p>

</xml_diff>